<commit_message>
Message flow diagram: request/response with requirement IDs and SIQ counts
</commit_message>
<xml_diff>
--- a/CS-Testing/Features/SOW1-SOW2_Secure_Communication/03-Summary/SOW1-SOW2_Feature_Summary.pptx
+++ b/CS-Testing/Features/SOW1-SOW2_Secure_Communication/03-Summary/SOW1-SOW2_Feature_Summary.pptx
@@ -2429,7 +2429,7 @@
                 <a:ea typeface="Calibri" pitchFamily="34" charset="-122"/>
                 <a:cs typeface="Calibri" pitchFamily="34" charset="-120"/>
               </a:rPr>
-              <a:t>Message flow</a:t>
+              <a:t>Message flow: request and response</a:t>
             </a:r>
             <a:endParaRPr lang="en-US" sz="3000" dirty="0"/>
           </a:p>
@@ -2437,7 +2437,7 @@
       </p:sp>
       <p:pic>
         <p:nvPicPr>
-          <p:cNvPr id="3" name="Image 0" descr="/home/user/Mekra-cybersecurity-testing/CS-Testing/07-Summary/D1_Message_Flow.png">    </p:cNvPr>
+          <p:cNvPr id="3" name="Image 0" descr="/home/user/Mekra-cybersecurity-testing/CS-Testing/Features/SOW1-SOW2_Secure_Communication/03-Summary/diagrams/1_Message_Flow.png">    </p:cNvPr>
           <p:cNvPicPr>
             <a:picLocks noChangeAspect="1"/>
           </p:cNvPicPr>
@@ -2451,8 +2451,8 @@
         </p:blipFill>
         <p:spPr>
           <a:xfrm>
-            <a:off x="2210105" y="1097280"/>
-            <a:ext cx="7768742" cy="5394960"/>
+            <a:off x="4026993" y="1097280"/>
+            <a:ext cx="4134966" cy="5394960"/>
           </a:xfrm>
           <a:prstGeom prst="rect">
             <a:avLst/>
@@ -2532,7 +2532,7 @@
       </p:sp>
       <p:pic>
         <p:nvPicPr>
-          <p:cNvPr id="3" name="Image 0" descr="/home/user/Mekra-cybersecurity-testing/CS-Testing/07-Summary/D2_Connections.png">    </p:cNvPr>
+          <p:cNvPr id="3" name="Image 0" descr="/home/user/Mekra-cybersecurity-testing/CS-Testing/Features/SOW1-SOW2_Secure_Communication/03-Summary/diagrams/2_Connections.png">    </p:cNvPr>
           <p:cNvPicPr>
             <a:picLocks noChangeAspect="1"/>
           </p:cNvPicPr>
@@ -4004,7 +4004,7 @@
       </p:sp>
       <p:pic>
         <p:nvPicPr>
-          <p:cNvPr id="3" name="Image 0" descr="/home/user/Mekra-cybersecurity-testing/CS-Testing/07-Summary/D3_Review_Workflow.png">    </p:cNvPr>
+          <p:cNvPr id="3" name="Image 0" descr="/home/user/Mekra-cybersecurity-testing/CS-Testing/Features/SOW1-SOW2_Secure_Communication/03-Summary/diagrams/3_Review_Workflow.png">    </p:cNvPr>
           <p:cNvPicPr>
             <a:picLocks noChangeAspect="1"/>
           </p:cNvPicPr>
@@ -4826,7 +4826,7 @@
                 <a:ea typeface="Calibri" pitchFamily="34" charset="-122"/>
                 <a:cs typeface="Calibri" pitchFamily="34" charset="-120"/>
               </a:rPr>
-              <a:t>SIQ status: 50 SIQs, 10 of 55 requirements reviewed</a:t>
+              <a:t>SIQ status: 87 SIQs, 25 of 25 concept requirements reviewed</a:t>
             </a:r>
             <a:endParaRPr lang="en-US" sz="3000" dirty="0"/>
           </a:p>
@@ -7951,7 +7951,7 @@
       </p:sp>
       <p:pic>
         <p:nvPicPr>
-          <p:cNvPr id="3" name="Image 0" descr="/home/user/Mekra-cybersecurity-testing/CS-Testing/07-Summary/D4_Test_Approach.png">    </p:cNvPr>
+          <p:cNvPr id="3" name="Image 0" descr="/home/user/Mekra-cybersecurity-testing/CS-Testing/Features/SOW1-SOW2_Secure_Communication/03-Summary/diagrams/4_Test_Approach.png">    </p:cNvPr>
           <p:cNvPicPr>
             <a:picLocks noChangeAspect="1"/>
           </p:cNvPicPr>

</xml_diff>